<commit_message>
pptx generation with pythin-pptx
</commit_message>
<xml_diff>
--- a/generated_cvs/6a7ae1e539dae46e85b6b85b.pptx
+++ b/generated_cvs/6a7ae1e539dae46e85b6b85b.pptx
@@ -16882,7 +16882,7 @@
                   <a:schemeClr val="dk1"/>
                 </a:solidFill>
               </a:rPr>
-              <a:t>AI Developer &amp; Process Automation Specialist</a:t>
+              <a:t>AI Engineer &amp; Full-Stack Developer</a:t>
             </a:r>
             <a:endParaRPr sz="900" b="1" dirty="0">
               <a:solidFill>
@@ -16955,18 +16955,15 @@
           </a:bodyPr>
           <a:lstStyle/>
           <a:p>
+            <a:pPr algn="just" defTabSz="914378"/>
             <a:r>
-              <a:rPr lang="fr-FR" sz="750" b="1" dirty="0">
-                <a:latin typeface="Montserrat"/>
-              </a:rPr>
+              <a:rPr sz="750"/>
               <a:t>Computer Engineering - Data Science - ESPRIT (2025)</a:t>
             </a:r>
           </a:p>
           <a:p>
             <a:r>
-              <a:rPr lang="fr-FR" sz="750" b="1" dirty="0">
-                <a:latin typeface="Montserrat"/>
-              </a:rPr>
+              <a:rPr sz="750"/>
               <a:t>Pre-Engineering Degree - Mathematics/Physics - IPEIT (2019-2022)</a:t>
             </a:r>
           </a:p>
@@ -17003,10 +17000,13 @@
           </a:bodyPr>
           <a:lstStyle/>
           <a:p>
+            <a:pPr marL="177796" indent="-114297" algn="just" defTabSz="914378">
+              <a:buSzPts val="600"/>
+              <a:buFont typeface="Montserrat"/>
+              <a:buChar char="●"/>
+            </a:pPr>
             <a:r>
-              <a:rPr lang="fr-FR" sz="800" b="0" dirty="0">
-                <a:latin typeface="Montserrat"/>
-              </a:rPr>
+              <a:rPr sz="800"/>
               <a:t>Python  •  JavaScript  •  SQL  •  RAG  •  LLM  •  NLP  •  FastAPI  •  Flask  •  LlamaIndex  •  OpenAI API  •  ChromaDB  •  HuggingFace Transformers  •  Git  •  REST APIs  •  Docker</a:t>
             </a:r>
           </a:p>
@@ -17043,98 +17043,60 @@
           </a:bodyPr>
           <a:lstStyle/>
           <a:p>
+            <a:r>
+              <a:rPr b="1" sz="800"/>
+              <a:t>Tunisian banks | AI Engineer &amp; Full-Stack Developer :</a:t>
+            </a:r>
             <a:endParaRPr lang="fr-FR" sz="825" b="1" dirty="0"/>
           </a:p>
           <a:p>
+            <a:pPr marL="128588" indent="-128588">
+              <a:buFont typeface="Arial"/>
+              <a:buChar char="•"/>
+            </a:pPr>
             <a:r>
-              <a:rPr lang="fr-FR" sz="800" b="1" dirty="0">
-                <a:latin typeface="Montserrat"/>
-              </a:rPr>
-              <a:t>Devoteam Tunisia | AI Developer &amp; Process Automation Specialist :</a:t>
+              <a:rPr sz="800"/>
+              <a:t>Engineered a document intelligence pipeline using python-docx to extract structured BIA data from Word fiches with header-fingerprint table detection, robust to any fiche format across multiple bank clients.</a:t>
             </a:r>
           </a:p>
           <a:p>
             <a:pPr marL="128588" indent="-128588">
-              <a:buFont typeface="Arial" panose="020B0604020202020204" pitchFamily="34" charset="0"/>
+              <a:buFont typeface="Arial"/>
               <a:buChar char="•"/>
             </a:pPr>
             <a:r>
-              <a:rPr lang="fr-FR" sz="800" b="0" dirty="0">
-                <a:latin typeface="Montserrat"/>
-              </a:rPr>
-              <a:t>Developed a sequential collection engine capable of guiding users through complex professional assessment frameworks (business axes and sub-axes).</a:t>
+              <a:rPr sz="800"/>
+              <a:t>Implemented real-time DMIA propagation from Excel synthesis to all linked Word fiches, with fuzzy matching via rapidfuzz to handle department name variations across client templates.</a:t>
             </a:r>
           </a:p>
           <a:p>
             <a:pPr marL="128588" indent="-128588">
-              <a:buFont typeface="Arial" panose="020B0604020202020204" pitchFamily="34" charset="0"/>
+              <a:buFont typeface="Arial"/>
               <a:buChar char="•"/>
             </a:pPr>
             <a:r>
-              <a:rPr lang="fr-FR" sz="800" b="0" dirty="0">
-                <a:latin typeface="Montserrat"/>
-              </a:rPr>
-              <a:t>Ensured comprehensive information gathering by enforcing multi-step validation for each entry, including initial response, justification, real-world examples, and lessons learned.</a:t>
+              <a:rPr sz="800"/>
+              <a:t>Built a full-featured single-page application for creating and editing BIA fiches in the browser, with a live DMIA suggestion engine powered by SQLite historical activity data from prior bank engagements.</a:t>
             </a:r>
           </a:p>
           <a:p>
             <a:pPr marL="128588" indent="-128588">
-              <a:buFont typeface="Arial" panose="020B0604020202020204" pitchFamily="34" charset="0"/>
+              <a:buFont typeface="Arial"/>
               <a:buChar char="•"/>
             </a:pPr>
             <a:r>
-              <a:rPr lang="fr-FR" sz="800" b="0" dirty="0">
-                <a:latin typeface="Montserrat"/>
-              </a:rPr>
-              <a:t>Designed dynamic system prompts using GPT-4o to manage natural transitions between topics and adapt questioning based on the user's progress state.</a:t>
+              <a:rPr sz="800"/>
+              <a:t>Developed an intelligent recommendation system querying historical activity data via exact and keyword matching, surfacing benchmark DMIA values from previous Tunisian bank BIA projects.</a:t>
             </a:r>
           </a:p>
           <a:p>
             <a:pPr marL="128588" indent="-128588">
-              <a:buFont typeface="Arial" panose="020B0604020202020204" pitchFamily="34" charset="0"/>
+              <a:buFont typeface="Arial"/>
               <a:buChar char="•"/>
             </a:pPr>
             <a:r>
-              <a:rPr lang="fr-FR" sz="800" b="0" dirty="0">
-                <a:latin typeface="Montserrat"/>
-              </a:rPr>
-              <a:t>Implemented a robust session handling system allowing for smooth resumption of interrupted audits ("returning user logic") with immediate incremental saving to Excel via Pandas.</a:t>
-            </a:r>
-          </a:p>
-          <a:p>
-            <a:pPr marL="128588" indent="-128588">
-              <a:buFont typeface="Arial" panose="020B0604020202020204" pitchFamily="34" charset="0"/>
-              <a:buChar char="•"/>
-            </a:pPr>
-            <a:r>
-              <a:rPr lang="fr-FR" sz="800" b="0" dirty="0">
-                <a:latin typeface="Montserrat"/>
-              </a:rPr>
-              <a:t>Built a desktop application utilizing Flask for backend logic and threading to manage automated browser-based user interaction in secure local environments.</a:t>
-            </a:r>
-          </a:p>
-          <a:p>
-            <a:pPr marL="128588" indent="-128588">
-              <a:buFont typeface="Arial" panose="020B0604020202020204" pitchFamily="34" charset="0"/>
-              <a:buChar char="•"/>
-            </a:pPr>
-            <a:r>
-              <a:rPr lang="fr-FR" sz="800" b="0" dirty="0">
-                <a:latin typeface="Montserrat"/>
-              </a:rPr>
-              <a:t>Integrated utility functions for automated data cleaning, handling null values, and real-time synchronization between the AI agent and physical storage files.</a:t>
-            </a:r>
-          </a:p>
-          <a:p>
-            <a:pPr marL="128588" indent="-128588">
-              <a:buFont typeface="Arial" panose="020B0604020202020204" pitchFamily="34" charset="0"/>
-              <a:buChar char="•"/>
-            </a:pPr>
-            <a:r>
-              <a:rPr lang="fr-FR" sz="800" b="0" dirty="0">
-                <a:latin typeface="Montserrat"/>
-              </a:rPr>
-              <a:t>Developed command interception mechanisms (e.g., "STOP", "FIN") and personalized welcome messages based on semantic analysis of completed versus pending work.</a:t>
+              <a:rPr sz="800"/>
+              <a:t>Created an interactive org-tree visualizer parsing synthesis Excel files to render department hierarchies with DMIA heatmaps (critical/moderate/low) for executive-level BCP reporting.</a:t>
             </a:r>
           </a:p>
         </p:txBody>
@@ -17378,86 +17340,62 @@
           </a:bodyPr>
           <a:lstStyle/>
           <a:p>
-            <a:endParaRPr lang="fr-FR" sz="825" b="1" dirty="0"/>
-          </a:p>
-          <a:p>
+            <a:pPr marL="63499" algn="just" defTabSz="914378">
+              <a:buSzPts val="600"/>
+            </a:pPr>
             <a:r>
-              <a:rPr lang="fr-FR" sz="800" b="1" dirty="0">
-                <a:latin typeface="Montserrat"/>
-              </a:rPr>
+              <a:rPr b="1" sz="800"/>
               <a:t>Devoteam Tunisia | AI Conversational Agent Developer :</a:t>
             </a:r>
           </a:p>
           <a:p>
             <a:pPr marL="128588" indent="-128588">
-              <a:buFont typeface="Arial" panose="020B0604020202020204" pitchFamily="34" charset="0"/>
+              <a:buFont typeface="Arial"/>
               <a:buChar char="•"/>
             </a:pPr>
             <a:r>
-              <a:rPr lang="fr-FR" sz="800" b="0" dirty="0">
-                <a:latin typeface="Montserrat"/>
-              </a:rPr>
+              <a:rPr sz="800"/>
               <a:t>Implemented a vector search system using LlamaIndex and the bge-large-en-v1.5 embedding model to simultaneously index and query PDF data corpora and web scraping extractions.</a:t>
             </a:r>
           </a:p>
           <a:p>
             <a:pPr marL="128588" indent="-128588">
-              <a:buFont typeface="Arial" panose="020B0604020202020204" pitchFamily="34" charset="0"/>
+              <a:buFont typeface="Arial"/>
               <a:buChar char="•"/>
             </a:pPr>
             <a:r>
-              <a:rPr lang="fr-FR" sz="800" b="0" dirty="0">
-                <a:latin typeface="Montserrat"/>
-              </a:rPr>
+              <a:rPr sz="800"/>
               <a:t>Developed a preset management system (Direct, Detailed, Analytical, Coaching, Strategic) allowing instant modification of AI tone and response structure via natural language commands.</a:t>
             </a:r>
           </a:p>
           <a:p>
             <a:pPr marL="128588" indent="-128588">
-              <a:buFont typeface="Arial" panose="020B0604020202020204" pitchFamily="34" charset="0"/>
+              <a:buFont typeface="Arial"/>
               <a:buChar char="•"/>
             </a:pPr>
             <a:r>
-              <a:rPr lang="fr-FR" sz="800" b="0" dirty="0">
-                <a:latin typeface="Montserrat"/>
-              </a:rPr>
+              <a:rPr sz="800"/>
               <a:t>Created a module capable of detecting AI information gaps, soliciting missing data from the user, and integrating it into the vector base in real-time following authentication.</a:t>
             </a:r>
           </a:p>
           <a:p>
             <a:pPr marL="128588" indent="-128588">
-              <a:buFont typeface="Arial" panose="020B0604020202020204" pitchFamily="34" charset="0"/>
+              <a:buFont typeface="Arial"/>
               <a:buChar char="•"/>
             </a:pPr>
             <a:r>
-              <a:rPr lang="fr-FR" sz="800" b="0" dirty="0">
-                <a:latin typeface="Montserrat"/>
-              </a:rPr>
+              <a:rPr sz="800"/>
               <a:t>Established a priority correction flow allowing the CEO to directly rectify AI responses; these corrections are vectorized and injected with absolute priority into the context of future queries.</a:t>
             </a:r>
           </a:p>
           <a:p>
             <a:pPr marL="128588" indent="-128588">
-              <a:buFont typeface="Arial" panose="020B0604020202020204" pitchFamily="34" charset="0"/>
+              <a:buFont typeface="Arial"/>
               <a:buChar char="•"/>
             </a:pPr>
             <a:r>
-              <a:rPr lang="fr-FR" sz="800" b="0" dirty="0">
-                <a:latin typeface="Montserrat"/>
-              </a:rPr>
+              <a:rPr sz="800"/>
               <a:t>Deployed a differential sanitization system using bleach for standard requests and a lightweight optimization for high-volume knowledge inputs up to 100,000 characters.</a:t>
-            </a:r>
-          </a:p>
-          <a:p>
-            <a:pPr marL="128588" indent="-128588">
-              <a:buFont typeface="Arial" panose="020B0604020202020204" pitchFamily="34" charset="0"/>
-              <a:buChar char="•"/>
-            </a:pPr>
-            <a:r>
-              <a:rPr lang="fr-FR" sz="800" b="0" dirty="0">
-                <a:latin typeface="Montserrat"/>
-              </a:rPr>
-              <a:t>Developed a secure administration interface to monitor system health, view interaction statistics, and analyze user feedback for continuous improvement.</a:t>
             </a:r>
           </a:p>
         </p:txBody>
@@ -17656,231 +17594,82 @@
           </a:bodyPr>
           <a:lstStyle/>
           <a:p>
+            <a:pPr marL="63499" algn="just" defTabSz="914378">
+              <a:buSzPts val="600"/>
+            </a:pPr>
             <a:r>
-              <a:rPr lang="fr-FR" sz="800" b="1" dirty="0">
-                <a:latin typeface="Montserrat"/>
-              </a:rPr>
-              <a:t>Tunisian banks | AI Engineer &amp; Full-Stack Developer :</a:t>
+              <a:rPr b="1" sz="800"/>
+              <a:t>Devoteam Tunisia | AI Developer &amp; Process Automation Specialist :</a:t>
             </a:r>
           </a:p>
           <a:p>
             <a:pPr marL="128588" indent="-128588">
-              <a:buFont typeface="Arial" panose="020B0604020202020204" pitchFamily="34" charset="0"/>
+              <a:buFont typeface="Arial"/>
               <a:buChar char="•"/>
             </a:pPr>
             <a:r>
-              <a:rPr lang="fr-FR" sz="800" b="0" dirty="0">
-                <a:latin typeface="Montserrat"/>
-              </a:rPr>
-              <a:t>Engineered a document intelligence pipeline using python-docx to extract structured BIA data from Word fiches with header-fingerprint table detection, robust to any fiche format across multiple bank clients.</a:t>
+              <a:rPr sz="800"/>
+              <a:t>Developed a sequential collection engine capable of guiding users through complex professional assessment frameworks (business axes and sub-axes).</a:t>
             </a:r>
           </a:p>
           <a:p>
             <a:pPr marL="128588" indent="-128588">
-              <a:buFont typeface="Arial" panose="020B0604020202020204" pitchFamily="34" charset="0"/>
+              <a:buFont typeface="Arial"/>
               <a:buChar char="•"/>
             </a:pPr>
             <a:r>
-              <a:rPr lang="fr-FR" sz="800" b="0" dirty="0">
-                <a:latin typeface="Montserrat"/>
-              </a:rPr>
-              <a:t>Implemented real-time DMIA propagation from Excel synthesis to all linked Word fiches, with fuzzy matching via rapidfuzz to handle department name variations across client templates.</a:t>
+              <a:rPr sz="800"/>
+              <a:t>Ensured comprehensive information gathering by enforcing multi-step validation for each entry, including initial response, justification, real-world examples, and lessons learned.</a:t>
             </a:r>
           </a:p>
           <a:p>
             <a:pPr marL="128588" indent="-128588">
-              <a:buFont typeface="Arial" panose="020B0604020202020204" pitchFamily="34" charset="0"/>
+              <a:buFont typeface="Arial"/>
               <a:buChar char="•"/>
             </a:pPr>
             <a:r>
-              <a:rPr lang="fr-FR" sz="800" b="0" dirty="0">
-                <a:latin typeface="Montserrat"/>
-              </a:rPr>
-              <a:t>Built a full-featured single-page application for creating and editing BIA fiches in the browser, with a live DMIA suggestion engine powered by SQLite historical activity data from prior bank engagements.</a:t>
+              <a:rPr sz="800"/>
+              <a:t>Designed dynamic system prompts using GPT-4o to manage natural transitions between topics and adapt questioning based on the user's progress state.</a:t>
             </a:r>
           </a:p>
           <a:p>
             <a:pPr marL="128588" indent="-128588">
-              <a:buFont typeface="Arial" panose="020B0604020202020204" pitchFamily="34" charset="0"/>
+              <a:buFont typeface="Arial"/>
               <a:buChar char="•"/>
             </a:pPr>
             <a:r>
-              <a:rPr lang="fr-FR" sz="800" b="0" dirty="0">
-                <a:latin typeface="Montserrat"/>
-              </a:rPr>
-              <a:t>Developed an intelligent recommendation system querying historical activity data via exact and keyword matching, surfacing benchmark DMIA values from previous Tunisian bank BIA projects.</a:t>
+              <a:rPr sz="800"/>
+              <a:t>Implemented a robust session handling system allowing for smooth resumption of interrupted audits ("returning user logic") with immediate incremental saving to Excel via Pandas.</a:t>
             </a:r>
           </a:p>
           <a:p>
             <a:pPr marL="128588" indent="-128588">
-              <a:buFont typeface="Arial" panose="020B0604020202020204" pitchFamily="34" charset="0"/>
+              <a:buFont typeface="Arial"/>
               <a:buChar char="•"/>
             </a:pPr>
             <a:r>
-              <a:rPr lang="fr-FR" sz="800" b="0" dirty="0">
-                <a:latin typeface="Montserrat"/>
-              </a:rPr>
-              <a:t>Created an interactive org-tree visualizer parsing synthesis Excel files to render department hierarchies with DMIA heatmaps (critical/moderate/low) for executive-level BCP reporting.</a:t>
+              <a:rPr sz="800"/>
+              <a:t>Built a desktop application utilizing Flask for backend logic and threading to manage automated browser-based user interaction in secure local environments.</a:t>
             </a:r>
           </a:p>
           <a:p>
             <a:pPr marL="128588" indent="-128588">
-              <a:buFont typeface="Arial" panose="020B0604020202020204" pitchFamily="34" charset="0"/>
+              <a:buFont typeface="Arial"/>
               <a:buChar char="•"/>
             </a:pPr>
             <a:r>
-              <a:rPr lang="fr-FR" sz="800" b="0" dirty="0">
-                <a:latin typeface="Montserrat"/>
-              </a:rPr>
-              <a:t>Designed an automated document generation pipeline producing one formatted Word fiche per department from a recensement Excel file, with LLM fallback via Ollama for unstructured content extraction.</a:t>
-            </a:r>
-          </a:p>
-          <a:p>
-            <a:r>
-              <a:rPr lang="fr-FR" sz="800" b="1" dirty="0">
-                <a:latin typeface="Montserrat"/>
-              </a:rPr>
-              <a:t>Devoteam Tunisia | Fullstack AI &amp; Process Automation Developer :</a:t>
+              <a:rPr sz="800"/>
+              <a:t>Integrated utility functions for automated data cleaning, handling null values, and real-time synchronization between the AI agent and physical storage files.</a:t>
             </a:r>
           </a:p>
           <a:p>
             <a:pPr marL="128588" indent="-128588">
-              <a:buFont typeface="Arial" panose="020B0604020202020204" pitchFamily="34" charset="0"/>
+              <a:buFont typeface="Arial"/>
               <a:buChar char="•"/>
             </a:pPr>
             <a:r>
-              <a:rPr lang="fr-FR" sz="800" b="0" dirty="0">
-                <a:latin typeface="Montserrat"/>
-              </a:rPr>
-              <a:t>Engineered a high-performance data ingestion pipeline for complex technical documents (PDF, XLSX, and PPTX) using ChromaDB as a vector store and OpenAI’s GPT-4o for precise multi-phase knowledge extraction.</a:t>
-            </a:r>
-          </a:p>
-          <a:p>
-            <a:pPr marL="128588" indent="-128588">
-              <a:buFont typeface="Arial" panose="020B0604020202020204" pitchFamily="34" charset="0"/>
-              <a:buChar char="•"/>
-            </a:pPr>
-            <a:r>
-              <a:rPr lang="fr-FR" sz="800" b="0" dirty="0">
-                <a:latin typeface="Montserrat"/>
-              </a:rPr>
-              <a:t>Developed a logic layer capable of converting unstructured natural language descriptions into valid BPMN 2.0 XML/JSON structures through a multi-provider LLM facade (OpenAI, Anthropic, Gemini).</a:t>
-            </a:r>
-          </a:p>
-          <a:p>
-            <a:pPr marL="128588" indent="-128588">
-              <a:buFont typeface="Arial" panose="020B0604020202020204" pitchFamily="34" charset="0"/>
-              <a:buChar char="•"/>
-            </a:pPr>
-            <a:r>
-              <a:rPr lang="fr-FR" sz="800" b="0" dirty="0">
-                <a:latin typeface="Montserrat"/>
-              </a:rPr>
-              <a:t>Built a sophisticated editing service that allows users to modify diagrams via conversation, supporting complex operations like element redirection, node movement, and automated gateway management.</a:t>
-            </a:r>
-          </a:p>
-          <a:p>
-            <a:pPr marL="128588" indent="-128588">
-              <a:buFont typeface="Arial" panose="020B0604020202020204" pitchFamily="34" charset="0"/>
-              <a:buChar char="•"/>
-            </a:pPr>
-            <a:r>
-              <a:rPr lang="fr-FR" sz="800" b="0" dirty="0">
-                <a:latin typeface="Montserrat"/>
-              </a:rPr>
-              <a:t>Integrated bpmn-js for real-time diagram rendering and implemented a dedicated layout microservice to automatically organize AI-generated process flows for optimal readability.</a:t>
-            </a:r>
-          </a:p>
-          <a:p>
-            <a:pPr marL="128588" indent="-128588">
-              <a:buFont typeface="Arial" panose="020B0604020202020204" pitchFamily="34" charset="0"/>
-              <a:buChar char="•"/>
-            </a:pPr>
-            <a:r>
-              <a:rPr lang="fr-FR" sz="800" b="0" dirty="0">
-                <a:latin typeface="Montserrat"/>
-              </a:rPr>
-              <a:t>Designed an advanced UI feature that synchronizes AI responses with a synchronized PDF viewer, allowing users to instantly preview exact document pages cited as sources for total transparency.</a:t>
-            </a:r>
-          </a:p>
-          <a:p>
-            <a:pPr marL="128588" indent="-128588">
-              <a:buFont typeface="Arial" panose="020B0604020202020204" pitchFamily="34" charset="0"/>
-              <a:buChar char="•"/>
-            </a:pPr>
-            <a:r>
-              <a:rPr lang="fr-FR" sz="800" b="0" dirty="0">
-                <a:latin typeface="Montserrat"/>
-              </a:rPr>
-              <a:t>Implemented internal session token security for FastAPI endpoints and optimized the user experience using server-sent events (StreamingResponse) for real-time AI "thinking" and text generation.</a:t>
-            </a:r>
-          </a:p>
-          <a:p>
-            <a:r>
-              <a:rPr lang="fr-FR" sz="800" b="1" dirty="0">
-                <a:latin typeface="Montserrat"/>
-              </a:rPr>
-              <a:t>Devoteam Tunisia | AI &amp; Data Automation Engineer :</a:t>
-            </a:r>
-          </a:p>
-          <a:p>
-            <a:pPr marL="128588" indent="-128588">
-              <a:buFont typeface="Arial" panose="020B0604020202020204" pitchFamily="34" charset="0"/>
-              <a:buChar char="•"/>
-            </a:pPr>
-            <a:r>
-              <a:rPr lang="fr-FR" sz="800" b="0" dirty="0">
-                <a:latin typeface="Montserrat"/>
-              </a:rPr>
-              <a:t>Developed a search functionality using cosine similarity relevance thresholding to match specific client needs (e.g., "Cloud Migration") with the most relevant consultant profiles and references.</a:t>
-            </a:r>
-          </a:p>
-          <a:p>
-            <a:pPr marL="128588" indent="-128588">
-              <a:buFont typeface="Arial" panose="020B0604020202020204" pitchFamily="34" charset="0"/>
-              <a:buChar char="•"/>
-            </a:pPr>
-            <a:r>
-              <a:rPr lang="fr-FR" sz="800" b="0" dirty="0">
-                <a:latin typeface="Montserrat"/>
-              </a:rPr>
-              <a:t>Built a template projection engine using libraries to map structured Markdown data into branded Word and PowerPoint templates, achieving 100% automated graphical formatting.</a:t>
-            </a:r>
-          </a:p>
-          <a:p>
-            <a:pPr marL="128588" indent="-128588">
-              <a:buFont typeface="Arial" panose="020B0604020202020204" pitchFamily="34" charset="0"/>
-              <a:buChar char="•"/>
-            </a:pPr>
-            <a:r>
-              <a:rPr lang="fr-FR" sz="800" b="0" dirty="0">
-                <a:latin typeface="Montserrat"/>
-              </a:rPr>
-              <a:t>Implemented logic allowing managers to dynamically reorder, hide, or adapt mission descriptions based on specific bid contexts and client technical stacks.</a:t>
-            </a:r>
-          </a:p>
-          <a:p>
-            <a:pPr marL="128588" indent="-128588">
-              <a:buFont typeface="Arial" panose="020B0604020202020204" pitchFamily="34" charset="0"/>
-              <a:buChar char="•"/>
-            </a:pPr>
-            <a:r>
-              <a:rPr lang="fr-FR" sz="800" b="0" dirty="0">
-                <a:latin typeface="Montserrat"/>
-              </a:rPr>
-              <a:t>Leveraged GPT-4o Vision capabilities to convert legacy PDF layouts into base64 images for flawless data extraction from complex, non-standardized CV formats.</a:t>
-            </a:r>
-          </a:p>
-          <a:p>
-            <a:pPr marL="128588" indent="-128588">
-              <a:buFont typeface="Arial" panose="020B0604020202020204" pitchFamily="34" charset="0"/>
-              <a:buChar char="•"/>
-            </a:pPr>
-            <a:r>
-              <a:rPr lang="fr-FR" sz="800" b="0" dirty="0">
-                <a:latin typeface="Montserrat"/>
-              </a:rPr>
-              <a:t>Reduced proposal preparation effort from 2-3 man-days to under one hour per file while securing internal API calls with server-side generated tokens and Role-Based Access Control (RBAC).</a:t>
+              <a:rPr sz="800"/>
+              <a:t>Developed command interception mechanisms (e.g., "STOP", "FIN") and personalized welcome messages based on semantic analysis of completed versus pending work.</a:t>
             </a:r>
           </a:p>
         </p:txBody>
@@ -17913,83 +17702,62 @@
           </a:bodyPr>
           <a:lstStyle/>
           <a:p>
+            <a:pPr marL="63499" algn="just" defTabSz="914378">
+              <a:buSzPts val="600"/>
+            </a:pPr>
             <a:r>
-              <a:rPr lang="fr-FR" sz="800" b="1" dirty="0">
-                <a:latin typeface="Montserrat"/>
-              </a:rPr>
-              <a:t>SNDP | AI Fullstack engineer :</a:t>
+              <a:rPr b="1" sz="800"/>
+              <a:t>Devoteam Tunisia | AI &amp; Data Automation Engineer :</a:t>
             </a:r>
           </a:p>
           <a:p>
             <a:pPr marL="128588" indent="-128588">
-              <a:buFont typeface="Arial" panose="020B0604020202020204" pitchFamily="34" charset="0"/>
+              <a:buFont typeface="Arial"/>
               <a:buChar char="•"/>
             </a:pPr>
             <a:r>
-              <a:rPr lang="fr-FR" sz="800" b="0" dirty="0">
-                <a:latin typeface="Montserrat"/>
-              </a:rPr>
-              <a:t>Implemented a multimodal processing pipeline utilizing GPT-4o Vision to visually analyze BPMN diagrams embedded within PowerPoint presentations.</a:t>
+              <a:rPr sz="800"/>
+              <a:t>Developed a search functionality using cosine similarity relevance thresholding to match specific client needs (e.g., "Cloud Migration") with the most relevant consultant profiles and references.</a:t>
             </a:r>
           </a:p>
           <a:p>
             <a:pPr marL="128588" indent="-128588">
-              <a:buFont typeface="Arial" panose="020B0604020202020204" pitchFamily="34" charset="0"/>
+              <a:buFont typeface="Arial"/>
               <a:buChar char="•"/>
             </a:pPr>
             <a:r>
-              <a:rPr lang="fr-FR" sz="800" b="0" dirty="0">
-                <a:latin typeface="Montserrat"/>
-              </a:rPr>
-              <a:t>Engineered a specialized BPMN 2.0 parser in Python using lxml to extract and sequence flows, gateways, and swim-lanes, providing structured context for the Large Language Model.</a:t>
+              <a:rPr sz="800"/>
+              <a:t>Built a template projection engine using libraries to map structured Markdown data into branded Word and PowerPoint templates, achieving 100% automated graphical formatting.</a:t>
             </a:r>
           </a:p>
           <a:p>
             <a:pPr marL="128588" indent="-128588">
-              <a:buFont typeface="Arial" panose="020B0604020202020204" pitchFamily="34" charset="0"/>
+              <a:buFont typeface="Arial"/>
               <a:buChar char="•"/>
             </a:pPr>
             <a:r>
-              <a:rPr lang="fr-FR" sz="800" b="0" dirty="0">
-                <a:latin typeface="Montserrat"/>
-              </a:rPr>
-              <a:t>Integrated a formatted Word document generation module using python-docx with branded styling, including operational tables, internal controls, and embedded diagrams.</a:t>
+              <a:rPr sz="800"/>
+              <a:t>Implemented logic allowing managers to dynamically reorder, hide, or adapt mission descriptions based on specific bid contexts and client technical stacks.</a:t>
             </a:r>
           </a:p>
           <a:p>
             <a:pPr marL="128588" indent="-128588">
-              <a:buFont typeface="Arial" panose="020B0604020202020204" pitchFamily="34" charset="0"/>
+              <a:buFont typeface="Arial"/>
               <a:buChar char="•"/>
             </a:pPr>
             <a:r>
-              <a:rPr lang="fr-FR" sz="800" b="0" dirty="0">
-                <a:latin typeface="Montserrat"/>
-              </a:rPr>
-              <a:t>Established a FastAPI-based REST API with modular routing (slides, generate, bpmn) and an automated conversion pipeline (PPTX → PDF → PNG) via LibreOffice and pdf2image.</a:t>
+              <a:rPr sz="800"/>
+              <a:t>Leveraged GPT-4o Vision capabilities to convert legacy PDF layouts into base64 images for flawless data extraction from complex, non-standardized CV formats.</a:t>
             </a:r>
           </a:p>
           <a:p>
             <a:pPr marL="128588" indent="-128588">
-              <a:buFont typeface="Arial" panose="020B0604020202020204" pitchFamily="34" charset="0"/>
+              <a:buFont typeface="Arial"/>
               <a:buChar char="•"/>
             </a:pPr>
             <a:r>
-              <a:rPr lang="fr-FR" sz="800" b="0" dirty="0">
-                <a:latin typeface="Montserrat"/>
-              </a:rPr>
-              <a:t>Authored structured JSON-based extraction prompts to produce procedural manuals with a cohesive narrative style consistent with professional SOP standards (e.g., Grant Thornton type).</a:t>
-            </a:r>
-          </a:p>
-          <a:p>
-            <a:pPr marL="128588" indent="-128588">
-              <a:buFont typeface="Arial" panose="020B0604020202020204" pitchFamily="34" charset="0"/>
-              <a:buChar char="•"/>
-            </a:pPr>
-            <a:r>
-              <a:rPr lang="fr-FR" sz="800" b="0" dirty="0">
-                <a:latin typeface="Montserrat"/>
-              </a:rPr>
-              <a:t>Leveraged AI Vision capabilities to bridge the gap between graphical process representations and technical documentation, ensuring 100% accuracy in step-by-step procedure mapping.</a:t>
+              <a:rPr sz="800"/>
+              <a:t>Reduced proposal preparation effort from 2-3 man-days to under one hour per file while securing internal API calls with server-side generated tokens and Role-Based Access Control (RBAC).</a:t>
             </a:r>
           </a:p>
         </p:txBody>
@@ -18636,7 +18404,7 @@
                   <a:schemeClr val="dk1"/>
                 </a:solidFill>
               </a:rPr>
-              <a:t>AI Developer &amp; Process Automation Specialist</a:t>
+              <a:t>AI Engineer &amp; Full-Stack Developer</a:t>
             </a:r>
             <a:endParaRPr lang="en-GB" sz="900" b="1" dirty="0">
               <a:solidFill>

</xml_diff>

<commit_message>
feat: add download all as zip
</commit_message>
<xml_diff>
--- a/generated_cvs/6a7ae1e539dae46e85b6b85b.pptx
+++ b/generated_cvs/6a7ae1e539dae46e85b6b85b.pptx
@@ -16665,7 +16665,8 @@
               <a:rPr lang="fr-FR" sz="800" dirty="0">
                 <a:latin typeface="Montserrat"/>
               </a:rPr>
-              <a:t>Results-driven AI Engineer specializing in production-grade AI systems combining Retrieval-Augmented Generation (RAG), Large Language Models, and real-time data pipelines. Currently building enterprise AI solutions at Devoteam Tunisia as a strategic AI copilot to executive leadership. Holder of DeepLearning.AI's full NLP Specialization (4 certificates, Nov 2024). Passionate about AI that creates measurable business impact.</a:t>
+              <a:t>RÉSUMÉ :
+Ingénieur IA axé sur les résultats, spécialisé dans les systèmes d'IA de niveau production combinant la génération augmentée par récupération (RAG), les grands modèles de langage (LLM) et les pipelines de données en temps réel. Actuellement en charge du développement de solutions d'IA d'entreprise chez Devoteam Tunisie en tant que copilote IA stratégique pour la direction exécutive. Titulaire de la spécialisation NLP complète de DeepLearning.AI (4 certificats, nov. 2024). Passionné par une IA qui crée un impact commercial mesurable.</a:t>
             </a:r>
             <a:endParaRPr sz="800" dirty="0">
               <a:solidFill>
@@ -17056,7 +17057,7 @@
             </a:pPr>
             <a:r>
               <a:rPr sz="800"/>
-              <a:t>Engineered a document intelligence pipeline using python-docx to extract structured BIA data from Word fiches with header-fingerprint table detection, robust to any fiche format across multiple bank clients.</a:t>
+              <a:t>Conception d'un pipeline d'intelligence documentaire utilisant python-docx pour extraire des données BIA structurées à partir de fiches Word avec détection de tableaux par empreinte d'en-tête, robuste pour tout format de…</a:t>
             </a:r>
           </a:p>
           <a:p>
@@ -17066,7 +17067,7 @@
             </a:pPr>
             <a:r>
               <a:rPr sz="800"/>
-              <a:t>Implemented real-time DMIA propagation from Excel synthesis to all linked Word fiches, with fuzzy matching via rapidfuzz to handle department name variations across client templates.</a:t>
+              <a:t>Mise en œuvre de la propagation DMIA en temps réel de la synthèse Excel vers toutes les fiches Word liées, avec fuzzy matching via rapidfuzz pour gérer les variations de noms de départements dans les modèles des clients.</a:t>
             </a:r>
           </a:p>
           <a:p>
@@ -17076,7 +17077,7 @@
             </a:pPr>
             <a:r>
               <a:rPr sz="800"/>
-              <a:t>Built a full-featured single-page application for creating and editing BIA fiches in the browser, with a live DMIA suggestion engine powered by SQLite historical activity data from prior bank engagements.</a:t>
+              <a:t>Construction d'une application monopage complète pour la création et l'édition de fiches BIA dans le navigateur, avec un moteur de suggestion DMIA en direct alimenté par les données d'activité historique SQLite issues d'…</a:t>
             </a:r>
           </a:p>
           <a:p>
@@ -17086,7 +17087,7 @@
             </a:pPr>
             <a:r>
               <a:rPr sz="800"/>
-              <a:t>Developed an intelligent recommendation system querying historical activity data via exact and keyword matching, surfacing benchmark DMIA values from previous Tunisian bank BIA projects.</a:t>
+              <a:t>Développement d'un système de recommandation intelligent interrogeant les données d'activité historique par correspondance exacte et par mots-clés, faisant ressortir les valeurs DMIA de référence à partir de projets BIA…</a:t>
             </a:r>
           </a:p>
           <a:p>
@@ -17096,7 +17097,7 @@
             </a:pPr>
             <a:r>
               <a:rPr sz="800"/>
-              <a:t>Created an interactive org-tree visualizer parsing synthesis Excel files to render department hierarchies with DMIA heatmaps (critical/moderate/low) for executive-level BCP reporting.</a:t>
+              <a:t>Création d'un visualiseur d'organigramme interactif analysant les fichiers Excel de synthèse pour rendre les hiérarchies de départements avec des cartes thermiques DMIA (critique/modéré/faible) pour le reporting BCP de n…</a:t>
             </a:r>
           </a:p>
         </p:txBody>
@@ -17355,7 +17356,7 @@
             </a:pPr>
             <a:r>
               <a:rPr sz="800"/>
-              <a:t>Implemented a vector search system using LlamaIndex and the bge-large-en-v1.5 embedding model to simultaneously index and query PDF data corpora and web scraping extractions.</a:t>
+              <a:t>Mise en œuvre d'un système de recherche vectorielle utilisant LlamaIndex et le modèle d'embedding bge-large-en-v1.5 pour indexer et interroger simultanément des corpus de données PDF et des extractions de web scraping.</a:t>
             </a:r>
           </a:p>
           <a:p>
@@ -17365,7 +17366,7 @@
             </a:pPr>
             <a:r>
               <a:rPr sz="800"/>
-              <a:t>Developed a preset management system (Direct, Detailed, Analytical, Coaching, Strategic) allowing instant modification of AI tone and response structure via natural language commands.</a:t>
+              <a:t>Développement d'un système de gestion des préréglages (Direct, Détaillé, Analytique, Coaching, Stratégique) permettant la modification instantanée du ton de l'IA et de la structure de réponse via des commandes en langage…</a:t>
             </a:r>
           </a:p>
           <a:p>
@@ -17375,7 +17376,7 @@
             </a:pPr>
             <a:r>
               <a:rPr sz="800"/>
-              <a:t>Created a module capable of detecting AI information gaps, soliciting missing data from the user, and integrating it into the vector base in real-time following authentication.</a:t>
+              <a:t>Création d'un module capable de détecter les lacunes d'information de l'IA, de solliciter les données manquantes auprès de l'utilisateur et de les intégrer dans la base vectorielle en temps réel après authentification.</a:t>
             </a:r>
           </a:p>
           <a:p>
@@ -17385,7 +17386,7 @@
             </a:pPr>
             <a:r>
               <a:rPr sz="800"/>
-              <a:t>Established a priority correction flow allowing the CEO to directly rectify AI responses; these corrections are vectorized and injected with absolute priority into the context of future queries.</a:t>
+              <a:t>Établissement d'un flux de correction prioritaire permettant au PDG de rectifier directement les réponses de l'IA ; ces corrections sont vectorisées et injectées avec une priorité absolue dans le contexte des requêtes fu…</a:t>
             </a:r>
           </a:p>
           <a:p>
@@ -17395,7 +17396,7 @@
             </a:pPr>
             <a:r>
               <a:rPr sz="800"/>
-              <a:t>Deployed a differential sanitization system using bleach for standard requests and a lightweight optimization for high-volume knowledge inputs up to 100,000 characters.</a:t>
+              <a:t>Déploiement d'un système de désinfection différentielle utilisant bleach pour les requêtes standard et une optimisation légère pour les entrées de connaissances à haut volume allant jusqu'à 100 000 caractères.</a:t>
             </a:r>
           </a:p>
         </p:txBody>
@@ -17609,7 +17610,7 @@
             </a:pPr>
             <a:r>
               <a:rPr sz="800"/>
-              <a:t>Developed a sequential collection engine capable of guiding users through complex professional assessment frameworks (business axes and sub-axes).</a:t>
+              <a:t>Développement d'un moteur de collecte séquentiel capable de guider les utilisateurs à travers des cadres d'évaluation professionnelle complexes (axes et sous-axes métier).</a:t>
             </a:r>
           </a:p>
           <a:p>
@@ -17619,7 +17620,7 @@
             </a:pPr>
             <a:r>
               <a:rPr sz="800"/>
-              <a:t>Ensured comprehensive information gathering by enforcing multi-step validation for each entry, including initial response, justification, real-world examples, and lessons learned.</a:t>
+              <a:t>Assurance d'une collecte d'informations exhaustive en imposant une validation multi-étapes pour chaque entrée, incluant la réponse initiale, la justification, des exemples concrets et les leçons apprises.</a:t>
             </a:r>
           </a:p>
           <a:p>
@@ -17629,7 +17630,7 @@
             </a:pPr>
             <a:r>
               <a:rPr sz="800"/>
-              <a:t>Designed dynamic system prompts using GPT-4o to manage natural transitions between topics and adapt questioning based on the user's progress state.</a:t>
+              <a:t>Conception de prompts système dynamiques utilisant GPT-4o pour gérer les transitions naturelles entre les sujets et adapter le questionnement en fonction de l'état d'avancement de l'utilisateur.</a:t>
             </a:r>
           </a:p>
           <a:p>
@@ -17639,7 +17640,7 @@
             </a:pPr>
             <a:r>
               <a:rPr sz="800"/>
-              <a:t>Implemented a robust session handling system allowing for smooth resumption of interrupted audits ("returning user logic") with immediate incremental saving to Excel via Pandas.</a:t>
+              <a:t>Mise en œuvre d'un système de gestion de session robuste permettant la reprise fluide d'audits interrompus (« logique de retour utilisateur ») avec sauvegarde incrémentale immédiate vers Excel via Pandas.</a:t>
             </a:r>
           </a:p>
           <a:p>
@@ -17649,7 +17650,7 @@
             </a:pPr>
             <a:r>
               <a:rPr sz="800"/>
-              <a:t>Built a desktop application utilizing Flask for backend logic and threading to manage automated browser-based user interaction in secure local environments.</a:t>
+              <a:t>Construction d'une application de bureau utilisant Flask pour la logique backend et le threading afin de gérer l'interaction utilisateur automatisée basée sur navigateur dans des environnements locaux sécurisés.</a:t>
             </a:r>
           </a:p>
           <a:p>
@@ -17659,7 +17660,7 @@
             </a:pPr>
             <a:r>
               <a:rPr sz="800"/>
-              <a:t>Integrated utility functions for automated data cleaning, handling null values, and real-time synchronization between the AI agent and physical storage files.</a:t>
+              <a:t>Intégration de fonctions utilitaires pour le nettoyage automatisé des données, la gestion des valeurs nulles et la synchronisation en temps réel entre l'agent IA et les fichiers de stockage physiques.</a:t>
             </a:r>
           </a:p>
           <a:p>
@@ -17669,7 +17670,7 @@
             </a:pPr>
             <a:r>
               <a:rPr sz="800"/>
-              <a:t>Developed command interception mechanisms (e.g., "STOP", "FIN") and personalized welcome messages based on semantic analysis of completed versus pending work.</a:t>
+              <a:t>Développement de mécanismes d'interception de commandes (par ex. « STOP », « FIN ») et de messages d'accueil personnalisés basés sur l'analyse sémantique du travail terminé versus en attente.</a:t>
             </a:r>
           </a:p>
         </p:txBody>
@@ -17705,60 +17706,6 @@
             <a:pPr marL="63499" algn="just" defTabSz="914378">
               <a:buSzPts val="600"/>
             </a:pPr>
-            <a:r>
-              <a:rPr b="1" sz="800"/>
-              <a:t>Devoteam Tunisia | AI &amp; Data Automation Engineer :</a:t>
-            </a:r>
-          </a:p>
-          <a:p>
-            <a:pPr marL="128588" indent="-128588">
-              <a:buFont typeface="Arial"/>
-              <a:buChar char="•"/>
-            </a:pPr>
-            <a:r>
-              <a:rPr sz="800"/>
-              <a:t>Developed a search functionality using cosine similarity relevance thresholding to match specific client needs (e.g., "Cloud Migration") with the most relevant consultant profiles and references.</a:t>
-            </a:r>
-          </a:p>
-          <a:p>
-            <a:pPr marL="128588" indent="-128588">
-              <a:buFont typeface="Arial"/>
-              <a:buChar char="•"/>
-            </a:pPr>
-            <a:r>
-              <a:rPr sz="800"/>
-              <a:t>Built a template projection engine using libraries to map structured Markdown data into branded Word and PowerPoint templates, achieving 100% automated graphical formatting.</a:t>
-            </a:r>
-          </a:p>
-          <a:p>
-            <a:pPr marL="128588" indent="-128588">
-              <a:buFont typeface="Arial"/>
-              <a:buChar char="•"/>
-            </a:pPr>
-            <a:r>
-              <a:rPr sz="800"/>
-              <a:t>Implemented logic allowing managers to dynamically reorder, hide, or adapt mission descriptions based on specific bid contexts and client technical stacks.</a:t>
-            </a:r>
-          </a:p>
-          <a:p>
-            <a:pPr marL="128588" indent="-128588">
-              <a:buFont typeface="Arial"/>
-              <a:buChar char="•"/>
-            </a:pPr>
-            <a:r>
-              <a:rPr sz="800"/>
-              <a:t>Leveraged GPT-4o Vision capabilities to convert legacy PDF layouts into base64 images for flawless data extraction from complex, non-standardized CV formats.</a:t>
-            </a:r>
-          </a:p>
-          <a:p>
-            <a:pPr marL="128588" indent="-128588">
-              <a:buFont typeface="Arial"/>
-              <a:buChar char="•"/>
-            </a:pPr>
-            <a:r>
-              <a:rPr sz="800"/>
-              <a:t>Reduced proposal preparation effort from 2-3 man-days to under one hour per file while securing internal API calls with server-side generated tokens and Role-Based Access Control (RBAC).</a:t>
-            </a:r>
           </a:p>
         </p:txBody>
       </p:sp>

</xml_diff>